<commit_message>
Update lecture 05 homology figure and remove agenda timings
</commit_message>
<xml_diff>
--- a/05_AlphaFold2による構造予測/05_AlphaFold2による構造予測.pptx
+++ b/05_AlphaFold2による構造予測/05_AlphaFold2による構造予測.pptx
@@ -2243,7 +2243,7 @@
               <a:rPr lang="ja-JP" altLang="en-US">
                 <a:ea typeface="Noto Sans JP"/>
               </a:rPr>
-              <a:t>座学60分の中で、導入と従来法を短く説明し、中心の時間はEvoformerと構造生成に使います。距離行列は共進化の前、内部座標と局所フレームはStructure Moduleの前で説明します。詳しい古典的手法とAttentionの復習は付録です。演習20分はColabFoldの操作と結果の観察に使い、採点や提出はありません。</a:t>
+              <a:t>導入と従来法を短く説明し、中心の時間はEvoformerと構造生成に使います。距離行列は共進化の前、内部座標と局所フレームはStructure Moduleの前で説明します。詳しい古典的手法とAttentionの復習は付録です。演習20分はColabFoldの操作と結果の観察に使い、採点や提出はありません。</a:t>
             </a:r>
           </a:p>
         </p:txBody>
@@ -4157,9 +4157,9 @@
           <a:p>
             <a:r>
               <a:rPr lang="ja-JP" altLang="en-US">
-                <a:latin typeface="Noto Sans JP"/>
-              </a:rPr>
-              <a:t>ホモロジーモデリングの流れを、左の図で順に見ます。まず、ターゲットの配列に似た配列を、PDB の中から BLAST などの検索ツールで探します。見つかったものがテンプレートの候補です。次に、テンプレートとターゲットの配列を並べて、どの残基がどの残基に対応するかを決めます。これを配列アラインメントといいます。対応が決まったら、テンプレートの構造にターゲットの配列を当てはめ、足りない側鎖やループの原子を足します。そのあと、分子動力学やモンテカルロ法で構造を少しずつ変えながら、たくさんの構造を作り、エネルギーやスコアで天然らしさを評価します。最後に、いちばん良い構造を選び、二面角が許される範囲にあるかなどを確かめます。うまくいかなければ、別のテンプレートでやり直します。</a:t>
+                <a:ea typeface="Noto Sans JP"/>
+              </a:rPr>
+              <a:t>図はProtein Actions日本語版の図11.1です。まず配列アラインメントによって、既知構造のどの残基が予測対象のどの残基に対応するかを決めます。テンプレートの骨格を使い、配列の違いに合わせて側鎖や挿入・欠失の部分を組み直します。一つの候補で決めず、複数の候補を作ってエネルギーやモデル評価のスコアで比べ、精密化します。図のTMスコアは参照構造に対する近さです。正解構造が未知の本番予測ではこの値を直接使えないため、利用可能なモデル評価のスコアで候補を選びます。要件を満たさなければ、テンプレートやアラインメントから見直します。</a:t>
             </a:r>
           </a:p>
         </p:txBody>
@@ -23527,7 +23527,7 @@
                 <a:latin typeface="Noto Sans JP"/>
                 <a:ea typeface="Noto Sans JP"/>
               </a:rPr>
-              <a:t>構造予測の出発点｜12分</a:t>
+              <a:t>構造予測の出発点</a:t>
             </a:r>
           </a:p>
         </p:txBody>
@@ -23607,7 +23607,7 @@
                 <a:latin typeface="Noto Sans JP"/>
                 <a:ea typeface="Noto Sans JP"/>
               </a:rPr>
-              <a:t>Evoformer｜20分</a:t>
+              <a:t>Evoformer</a:t>
             </a:r>
           </a:p>
         </p:txBody>
@@ -23687,7 +23687,7 @@
                 <a:latin typeface="Noto Sans JP"/>
                 <a:ea typeface="Noto Sans JP"/>
               </a:rPr>
-              <a:t>Structure Module｜20分</a:t>
+              <a:t>Structure Module</a:t>
             </a:r>
           </a:p>
         </p:txBody>
@@ -23767,7 +23767,7 @@
                 <a:latin typeface="Noto Sans JP"/>
                 <a:ea typeface="Noto Sans JP"/>
               </a:rPr>
-              <a:t>信頼度とまとめ｜8分</a:t>
+              <a:t>信頼度とまとめ</a:t>
             </a:r>
           </a:p>
         </p:txBody>
@@ -27834,7 +27834,7 @@
                 <a:latin typeface="Noto Sans JP"/>
                 <a:ea typeface="Noto Sans JP"/>
               </a:rPr>
-              <a:t>付録は授業60分に追加して説明する前提ではない。</a:t>
+              <a:t>付録は自習・復習用の補足資料です。</a:t>
             </a:r>
           </a:p>
         </p:txBody>
@@ -41800,7 +41800,7 @@
           <a:p>
             <a:pPr algn="l">
               <a:lnSpc>
-                <a:spcPts val="1760"/>
+                <a:spcPct val="110000"/>
               </a:lnSpc>
             </a:pPr>
             <a:r>
@@ -41915,7 +41915,7 @@
           <a:p>
             <a:pPr algn="r">
               <a:lnSpc>
-                <a:spcPts val="1050"/>
+                <a:spcPct val="100000"/>
               </a:lnSpc>
             </a:pPr>
             <a:r>
@@ -41933,7 +41933,7 @@
       </p:sp>
       <p:pic>
         <p:nvPicPr>
-          <p:cNvPr id="6" name="Picture 5" descr="hm_steps.png"/>
+          <p:cNvPr id="6" name="Picture 5" descr="protein_actions_fig11_1.png"/>
           <p:cNvPicPr>
             <a:picLocks noChangeAspect="1"/>
           </p:cNvPicPr>
@@ -41947,8 +41947,8 @@
         </p:blipFill>
         <p:spPr>
           <a:xfrm>
-            <a:off x="975213" y="1371600"/>
-            <a:ext cx="6950343" cy="3608832"/>
+            <a:off x="1349692" y="1280160"/>
+            <a:ext cx="9462134" cy="4773168"/>
           </a:xfrm>
           <a:prstGeom prst="rect">
             <a:avLst/>
@@ -41963,94 +41963,8 @@
         </p:nvSpPr>
         <p:spPr>
           <a:xfrm>
-            <a:off x="609904" y="5026151"/>
-            <a:ext cx="7680960" cy="204216"/>
-          </a:xfrm>
-          <a:prstGeom prst="rect">
-            <a:avLst/>
-          </a:prstGeom>
-          <a:noFill/>
-        </p:spPr>
-        <p:txBody>
-          <a:bodyPr wrap="square" lIns="0" rIns="0" tIns="0" bIns="0" anchor="t">
-            <a:noAutofit/>
-          </a:bodyPr>
-          <a:lstStyle/>
-          <a:p>
-            <a:pPr algn="ctr">
-              <a:lnSpc>
-                <a:spcPts val="1320"/>
-              </a:lnSpc>
-            </a:pPr>
-            <a:r>
-              <a:rPr sz="1100" b="0" lang="ja-JP" altLang="en-US">
-                <a:solidFill>
-                  <a:srgbClr val="666666"/>
-                </a:solidFill>
-                <a:latin typeface="Noto Sans JP"/>
-                <a:ea typeface="Noto Sans JP"/>
-              </a:rPr>
-              <a:t>ホモロジーモデリングの手順（模式図）</a:t>
-            </a:r>
-          </a:p>
-        </p:txBody>
-      </p:sp>
-      <p:sp>
-        <p:nvSpPr>
-          <p:cNvPr id="8" name="Rounded Rectangle 7"/>
-          <p:cNvSpPr/>
-          <p:nvPr/>
-        </p:nvSpPr>
-        <p:spPr>
-          <a:xfrm>
-            <a:off x="8473744" y="1371600"/>
-            <a:ext cx="3108045" cy="4699635"/>
-          </a:xfrm>
-          <a:prstGeom prst="roundRect">
-            <a:avLst>
-              <a:gd name="adj" fmla="val 3530"/>
-            </a:avLst>
-          </a:prstGeom>
-          <a:solidFill>
-            <a:srgbClr val="E8F1FE"/>
-          </a:solidFill>
-          <a:ln>
-            <a:noFill/>
-          </a:ln>
-          <a:effectLst/>
-        </p:spPr>
-        <p:style>
-          <a:lnRef idx="1">
-            <a:schemeClr val="accent1"/>
-          </a:lnRef>
-          <a:fillRef idx="3">
-            <a:schemeClr val="accent1"/>
-          </a:fillRef>
-          <a:effectRef idx="2">
-            <a:schemeClr val="accent1"/>
-          </a:effectRef>
-          <a:fontRef idx="minor">
-            <a:schemeClr val="lt1"/>
-          </a:fontRef>
-        </p:style>
-        <p:txBody>
-          <a:bodyPr rtlCol="0" anchor="ctr"/>
-          <a:lstStyle/>
-          <a:p>
-            <a:pPr algn="ctr"/>
-          </a:p>
-        </p:txBody>
-      </p:sp>
-      <p:sp>
-        <p:nvSpPr>
-          <p:cNvPr id="9" name="TextBox 8"/>
-          <p:cNvSpPr txBox="1"/>
-          <p:nvPr/>
-        </p:nvSpPr>
-        <p:spPr>
-          <a:xfrm>
-            <a:off x="8638336" y="1536192"/>
-            <a:ext cx="2778861" cy="331851"/>
+            <a:off x="658368" y="6108192"/>
+            <a:ext cx="10972800" cy="265176"/>
           </a:xfrm>
           <a:prstGeom prst="rect">
             <a:avLst/>
@@ -42065,32 +41979,32 @@
           <a:p>
             <a:pPr algn="l">
               <a:lnSpc>
-                <a:spcPts val="2325"/>
-              </a:lnSpc>
-            </a:pPr>
-            <a:r>
-              <a:rPr sz="1500" b="1" lang="ja-JP" altLang="en-US">
-                <a:solidFill>
-                  <a:srgbClr val="1A1A1A"/>
-                </a:solidFill>
-                <a:latin typeface="Noto Sans JP"/>
-                <a:ea typeface="Noto Sans JP"/>
-              </a:rPr>
-              <a:t>手順</a:t>
-            </a:r>
-          </a:p>
-        </p:txBody>
-      </p:sp>
-      <p:sp>
-        <p:nvSpPr>
-          <p:cNvPr id="10" name="TextBox 9"/>
-          <p:cNvSpPr txBox="1"/>
-          <p:nvPr/>
-        </p:nvSpPr>
-        <p:spPr>
-          <a:xfrm>
-            <a:off x="8638336" y="1922907"/>
-            <a:ext cx="2778861" cy="587756"/>
+                <a:spcPts val="1820"/>
+              </a:lnSpc>
+            </a:pPr>
+            <a:r>
+              <a:rPr sz="1300" b="0" lang="ja-JP" altLang="en-US">
+                <a:solidFill>
+                  <a:srgbClr val="333333"/>
+                </a:solidFill>
+                <a:latin typeface="Noto Sans JP"/>
+                <a:ea typeface="Noto Sans JP"/>
+              </a:rPr>
+              <a:t>TMスコアには参照構造が必要。正解構造が未知の予測では、利用可能なモデル評価のスコアで候補を選ぶ。</a:t>
+            </a:r>
+          </a:p>
+        </p:txBody>
+      </p:sp>
+      <p:sp>
+        <p:nvSpPr>
+          <p:cNvPr id="8" name="TextBox 7"/>
+          <p:cNvSpPr txBox="1"/>
+          <p:nvPr/>
+        </p:nvSpPr>
+        <p:spPr>
+          <a:xfrm>
+            <a:off x="658368" y="6419088"/>
+            <a:ext cx="10515600" cy="201168"/>
           </a:xfrm>
           <a:prstGeom prst="rect">
             <a:avLst/>
@@ -42105,304 +42019,18 @@
           <a:p>
             <a:pPr algn="l">
               <a:lnSpc>
-                <a:spcPts val="2170"/>
-              </a:lnSpc>
-            </a:pPr>
-            <a:r>
-              <a:rPr sz="1400" b="0" lang="ja-JP" altLang="en-US">
+                <a:spcPts val="1400"/>
+              </a:lnSpc>
+            </a:pPr>
+            <a:r>
+              <a:rPr sz="1000" b="0" lang="ja-JP" altLang="en-US">
                 <a:solidFill>
                   <a:srgbClr val="333333"/>
                 </a:solidFill>
                 <a:latin typeface="Noto Sans JP"/>
                 <a:ea typeface="Noto Sans JP"/>
               </a:rPr>
-              <a:t>① PDB で似た配列を探す（BLAST）</a:t>
-            </a:r>
-          </a:p>
-        </p:txBody>
-      </p:sp>
-      <p:sp>
-        <p:nvSpPr>
-          <p:cNvPr id="11" name="TextBox 10"/>
-          <p:cNvSpPr txBox="1"/>
-          <p:nvPr/>
-        </p:nvSpPr>
-        <p:spPr>
-          <a:xfrm>
-            <a:off x="8638336" y="2602103"/>
-            <a:ext cx="2778861" cy="587756"/>
-          </a:xfrm>
-          <a:prstGeom prst="rect">
-            <a:avLst/>
-          </a:prstGeom>
-          <a:noFill/>
-        </p:spPr>
-        <p:txBody>
-          <a:bodyPr wrap="square" lIns="0" rIns="0" tIns="0" bIns="0" anchor="t">
-            <a:noAutofit/>
-          </a:bodyPr>
-          <a:lstStyle/>
-          <a:p>
-            <a:pPr algn="l">
-              <a:lnSpc>
-                <a:spcPts val="2170"/>
-              </a:lnSpc>
-            </a:pPr>
-            <a:r>
-              <a:rPr sz="1400" b="0" lang="ja-JP" altLang="en-US">
-                <a:solidFill>
-                  <a:srgbClr val="333333"/>
-                </a:solidFill>
-                <a:latin typeface="Noto Sans JP"/>
-                <a:ea typeface="Noto Sans JP"/>
-              </a:rPr>
-              <a:t>② テンプレートと配列を並べる（アラインメント）</a:t>
-            </a:r>
-          </a:p>
-        </p:txBody>
-      </p:sp>
-      <p:sp>
-        <p:nvSpPr>
-          <p:cNvPr id="12" name="TextBox 11"/>
-          <p:cNvSpPr txBox="1"/>
-          <p:nvPr/>
-        </p:nvSpPr>
-        <p:spPr>
-          <a:xfrm>
-            <a:off x="8638336" y="3281299"/>
-            <a:ext cx="2778861" cy="587756"/>
-          </a:xfrm>
-          <a:prstGeom prst="rect">
-            <a:avLst/>
-          </a:prstGeom>
-          <a:noFill/>
-        </p:spPr>
-        <p:txBody>
-          <a:bodyPr wrap="square" lIns="0" rIns="0" tIns="0" bIns="0" anchor="t">
-            <a:noAutofit/>
-          </a:bodyPr>
-          <a:lstStyle/>
-          <a:p>
-            <a:pPr algn="l">
-              <a:lnSpc>
-                <a:spcPts val="2170"/>
-              </a:lnSpc>
-            </a:pPr>
-            <a:r>
-              <a:rPr sz="1400" b="0" lang="ja-JP" altLang="en-US">
-                <a:solidFill>
-                  <a:srgbClr val="333333"/>
-                </a:solidFill>
-                <a:latin typeface="Noto Sans JP"/>
-                <a:ea typeface="Noto Sans JP"/>
-              </a:rPr>
-              <a:t>③ 当てはめて、側鎖・ループの原子を足す</a:t>
-            </a:r>
-          </a:p>
-        </p:txBody>
-      </p:sp>
-      <p:sp>
-        <p:nvSpPr>
-          <p:cNvPr id="13" name="TextBox 12"/>
-          <p:cNvSpPr txBox="1"/>
-          <p:nvPr/>
-        </p:nvSpPr>
-        <p:spPr>
-          <a:xfrm>
-            <a:off x="8638336" y="3960495"/>
-            <a:ext cx="2778861" cy="587756"/>
-          </a:xfrm>
-          <a:prstGeom prst="rect">
-            <a:avLst/>
-          </a:prstGeom>
-          <a:noFill/>
-        </p:spPr>
-        <p:txBody>
-          <a:bodyPr wrap="square" lIns="0" rIns="0" tIns="0" bIns="0" anchor="t">
-            <a:noAutofit/>
-          </a:bodyPr>
-          <a:lstStyle/>
-          <a:p>
-            <a:pPr algn="l">
-              <a:lnSpc>
-                <a:spcPts val="2170"/>
-              </a:lnSpc>
-            </a:pPr>
-            <a:r>
-              <a:rPr sz="1400" b="0" lang="ja-JP" altLang="en-US">
-                <a:solidFill>
-                  <a:srgbClr val="333333"/>
-                </a:solidFill>
-                <a:latin typeface="Noto Sans JP"/>
-                <a:ea typeface="Noto Sans JP"/>
-              </a:rPr>
-              <a:t>④ 構造をたくさん作り、エネルギーやスコアで評価する</a:t>
-            </a:r>
-          </a:p>
-        </p:txBody>
-      </p:sp>
-      <p:sp>
-        <p:nvSpPr>
-          <p:cNvPr id="14" name="TextBox 13"/>
-          <p:cNvSpPr txBox="1"/>
-          <p:nvPr/>
-        </p:nvSpPr>
-        <p:spPr>
-          <a:xfrm>
-            <a:off x="8638336" y="4639691"/>
-            <a:ext cx="2778861" cy="587756"/>
-          </a:xfrm>
-          <a:prstGeom prst="rect">
-            <a:avLst/>
-          </a:prstGeom>
-          <a:noFill/>
-        </p:spPr>
-        <p:txBody>
-          <a:bodyPr wrap="square" lIns="0" rIns="0" tIns="0" bIns="0" anchor="t">
-            <a:noAutofit/>
-          </a:bodyPr>
-          <a:lstStyle/>
-          <a:p>
-            <a:pPr algn="l">
-              <a:lnSpc>
-                <a:spcPts val="2170"/>
-              </a:lnSpc>
-            </a:pPr>
-            <a:r>
-              <a:rPr sz="1400" b="0" lang="ja-JP" altLang="en-US">
-                <a:solidFill>
-                  <a:srgbClr val="333333"/>
-                </a:solidFill>
-                <a:latin typeface="Noto Sans JP"/>
-                <a:ea typeface="Noto Sans JP"/>
-              </a:rPr>
-              <a:t>⑤ 最良の構造を選び、精密化する</a:t>
-            </a:r>
-          </a:p>
-        </p:txBody>
-      </p:sp>
-      <p:sp>
-        <p:nvSpPr>
-          <p:cNvPr id="15" name="TextBox 14"/>
-          <p:cNvSpPr txBox="1"/>
-          <p:nvPr/>
-        </p:nvSpPr>
-        <p:spPr>
-          <a:xfrm>
-            <a:off x="8638336" y="5318886"/>
-            <a:ext cx="2778861" cy="587756"/>
-          </a:xfrm>
-          <a:prstGeom prst="rect">
-            <a:avLst/>
-          </a:prstGeom>
-          <a:noFill/>
-        </p:spPr>
-        <p:txBody>
-          <a:bodyPr wrap="square" lIns="0" rIns="0" tIns="0" bIns="0" anchor="t">
-            <a:noAutofit/>
-          </a:bodyPr>
-          <a:lstStyle/>
-          <a:p>
-            <a:pPr algn="l">
-              <a:lnSpc>
-                <a:spcPts val="2170"/>
-              </a:lnSpc>
-            </a:pPr>
-            <a:r>
-              <a:rPr sz="1400" b="0" lang="ja-JP" altLang="en-US">
-                <a:solidFill>
-                  <a:srgbClr val="333333"/>
-                </a:solidFill>
-                <a:latin typeface="Noto Sans JP"/>
-                <a:ea typeface="Noto Sans JP"/>
-              </a:rPr>
-              <a:t>⑥ 要件を満たさなければ、別のテンプレートでやり直す</a:t>
-            </a:r>
-          </a:p>
-        </p:txBody>
-      </p:sp>
-      <p:sp>
-        <p:nvSpPr>
-          <p:cNvPr id="16" name="Rounded Rectangle 15"/>
-          <p:cNvSpPr/>
-          <p:nvPr/>
-        </p:nvSpPr>
-        <p:spPr>
-          <a:xfrm>
-            <a:off x="609904" y="5353050"/>
-            <a:ext cx="7680960" cy="956310"/>
-          </a:xfrm>
-          <a:prstGeom prst="roundRect">
-            <a:avLst>
-              <a:gd name="adj" fmla="val 11474"/>
-            </a:avLst>
-          </a:prstGeom>
-          <a:solidFill>
-            <a:srgbClr val="F2F2F2"/>
-          </a:solidFill>
-          <a:ln>
-            <a:noFill/>
-          </a:ln>
-          <a:effectLst/>
-        </p:spPr>
-        <p:style>
-          <a:lnRef idx="1">
-            <a:schemeClr val="accent1"/>
-          </a:lnRef>
-          <a:fillRef idx="3">
-            <a:schemeClr val="accent1"/>
-          </a:fillRef>
-          <a:effectRef idx="2">
-            <a:schemeClr val="accent1"/>
-          </a:effectRef>
-          <a:fontRef idx="minor">
-            <a:schemeClr val="lt1"/>
-          </a:fontRef>
-        </p:style>
-        <p:txBody>
-          <a:bodyPr rtlCol="0" anchor="ctr"/>
-          <a:lstStyle/>
-          <a:p>
-            <a:pPr algn="ctr"/>
-          </a:p>
-        </p:txBody>
-      </p:sp>
-      <p:sp>
-        <p:nvSpPr>
-          <p:cNvPr id="17" name="TextBox 16"/>
-          <p:cNvSpPr txBox="1"/>
-          <p:nvPr/>
-        </p:nvSpPr>
-        <p:spPr>
-          <a:xfrm>
-            <a:off x="774496" y="5517642"/>
-            <a:ext cx="7351776" cy="627126"/>
-          </a:xfrm>
-          <a:prstGeom prst="rect">
-            <a:avLst/>
-          </a:prstGeom>
-          <a:noFill/>
-        </p:spPr>
-        <p:txBody>
-          <a:bodyPr wrap="square" lIns="0" rIns="0" tIns="0" bIns="0" anchor="t">
-            <a:noAutofit/>
-          </a:bodyPr>
-          <a:lstStyle/>
-          <a:p>
-            <a:pPr algn="l">
-              <a:lnSpc>
-                <a:spcPts val="2325"/>
-              </a:lnSpc>
-            </a:pPr>
-            <a:r>
-              <a:rPr sz="1500" b="0" lang="ja-JP" altLang="en-US">
-                <a:solidFill>
-                  <a:srgbClr val="333333"/>
-                </a:solidFill>
-                <a:latin typeface="Noto Sans JP"/>
-                <a:ea typeface="Noto Sans JP"/>
-              </a:rPr>
-              <a:t>天然らしさの評価には、物理的な自由エネルギーか、PDB から作る統計的ポテンシャル（後で説明）を使う。</a:t>
+              <a:t>出典：Bahar・Jernigan・Dill『タンパク質の動きと機能』（共立出版, 2026）図11.1。旧AlphaFold 2解説教材より再利用。</a:t>
             </a:r>
           </a:p>
         </p:txBody>

</xml_diff>